<commit_message>
docs: add one-page submission PDF + embed repo link in the deck
New docs/LearnFlow-Submission.pdf — a single-page brutalist overview with the GitHub repo link (clickable), quick-start, demo credentials and clickstream summary. Also adds the repo URL to the presentation's closing slide across all three formats (.pptx / .pdf / .html).
</commit_message>
<xml_diff>
--- a/docs/LearnFlow.pptx
+++ b/docs/LearnFlow.pptx
@@ -8356,14 +8356,77 @@
       </p:sp>
       <p:sp>
         <p:nvSpPr>
-          <p:cNvPr id="10" name="Text 8"/>
-          <p:cNvSpPr/>
-          <p:nvPr/>
-        </p:nvSpPr>
-        <p:spPr>
-          <a:xfrm>
-            <a:off x="566928" y="4343400"/>
-            <a:ext cx="11064240" cy="457200"/>
+          <p:cNvPr id="10" name="Text 8">
+            <a:hlinkClick r:id="rId1" tooltip=""/>
+          </p:cNvPr>
+          <p:cNvSpPr/>
+          <p:nvPr/>
+        </p:nvSpPr>
+        <p:spPr>
+          <a:xfrm>
+            <a:off x="566928" y="4315968"/>
+            <a:ext cx="11064240" cy="603504"/>
+          </a:xfrm>
+          <a:prstGeom prst="roundRect">
+            <a:avLst>
+              <a:gd name="adj" fmla="val 21212"/>
+            </a:avLst>
+          </a:prstGeom>
+          <a:solidFill>
+            <a:srgbClr val="4F46E5"/>
+          </a:solidFill>
+          <a:ln w="31750">
+            <a:solidFill>
+              <a:srgbClr val="17130D"/>
+            </a:solidFill>
+          </a:ln>
+          <a:effectLst>
+            <a:outerShdw sx="100000" sy="100000" kx="0" ky="0" algn="bl" rotWithShape="0" blurRad="101600" dist="50800" dir="2700000">
+              <a:srgbClr val="17130D">
+                <a:alpha val="100000"/>
+              </a:srgbClr>
+            </a:outerShdw>
+          </a:effectLst>
+        </p:spPr>
+        <p:txBody>
+          <a:bodyPr wrap="square" lIns="0" tIns="0" rIns="0" bIns="0" rtlCol="0" anchor="ctr"/>
+          <a:lstStyle/>
+          <a:p>
+            <a:pPr algn="ctr" indent="0" marL="0">
+              <a:buNone/>
+            </a:pPr>
+            <a:r>
+              <a:rPr lang="en-US" sz="1600" b="1" u="sng" dirty="0">
+                <a:solidFill>
+                  <a:srgbClr val="FFFFFF"/>
+                </a:solidFill>
+                <a:latin typeface="Courier New" pitchFamily="34" charset="0"/>
+                <a:ea typeface="Courier New" pitchFamily="34" charset="-122"/>
+                <a:cs typeface="Courier New" pitchFamily="34" charset="-120"/>
+                <a:hlinkClick r:id="rId1" invalidUrl="" action="" tgtFrame="" tooltip="" history="1" highlightClick="0" endSnd="0">
+                  <a:extLst>
+                    <a:ext uri="{A12FA001-AC4F-418D-AE19-62706E023703}">
+                      <ahyp:hlinkClr xmlns:ahyp="http://schemas.microsoft.com/office/drawing/2018/hyperlinkcolor" val="tx"/>
+                    </a:ext>
+                  </a:extLst>
+                </a:hlinkClick>
+              </a:rPr>
+              <a:t>GITHUB   github.com/luffy-taro-106/et-617-learnflow</a:t>
+            </a:r>
+            <a:endParaRPr lang="en-US" sz="1600" dirty="0"/>
+          </a:p>
+        </p:txBody>
+      </p:sp>
+      <p:sp>
+        <p:nvSpPr>
+          <p:cNvPr id="11" name="Text 9"/>
+          <p:cNvSpPr/>
+          <p:nvPr/>
+        </p:nvSpPr>
+        <p:spPr>
+          <a:xfrm>
+            <a:off x="530352" y="5074920"/>
+            <a:ext cx="10972800" cy="960120"/>
           </a:xfrm>
           <a:prstGeom prst="rect">
             <a:avLst/>
@@ -8372,53 +8435,14 @@
           <a:ln/>
         </p:spPr>
         <p:txBody>
-          <a:bodyPr wrap="square" lIns="0" tIns="0" rIns="0" bIns="0" rtlCol="0" anchor="ctr"/>
+          <a:bodyPr wrap="square" rtlCol="0" anchor="ctr"/>
           <a:lstStyle/>
           <a:p>
             <a:pPr algn="l" indent="0" marL="0">
               <a:buNone/>
             </a:pPr>
             <a:r>
-              <a:rPr lang="en-US" sz="1550" dirty="0">
-                <a:solidFill>
-                  <a:srgbClr val="6C5D47"/>
-                </a:solidFill>
-                <a:latin typeface="Arial" pitchFamily="34" charset="0"/>
-                <a:ea typeface="Arial" pitchFamily="34" charset="-122"/>
-                <a:cs typeface="Arial" pitchFamily="34" charset="-120"/>
-              </a:rPr>
-              <a:t>Repo includes README, ARCHITECTURE.md, this deck, a demo video &amp; voice-over script.</a:t>
-            </a:r>
-            <a:endParaRPr lang="en-US" sz="1550" dirty="0"/>
-          </a:p>
-        </p:txBody>
-      </p:sp>
-      <p:sp>
-        <p:nvSpPr>
-          <p:cNvPr id="11" name="Text 9"/>
-          <p:cNvSpPr/>
-          <p:nvPr/>
-        </p:nvSpPr>
-        <p:spPr>
-          <a:xfrm>
-            <a:off x="530352" y="4892040"/>
-            <a:ext cx="10972800" cy="1005840"/>
-          </a:xfrm>
-          <a:prstGeom prst="rect">
-            <a:avLst/>
-          </a:prstGeom>
-          <a:noFill/>
-          <a:ln/>
-        </p:spPr>
-        <p:txBody>
-          <a:bodyPr wrap="square" rtlCol="0" anchor="ctr"/>
-          <a:lstStyle/>
-          <a:p>
-            <a:pPr algn="l" indent="0" marL="0">
-              <a:buNone/>
-            </a:pPr>
-            <a:r>
-              <a:rPr lang="en-US" sz="5400" b="1" spc="-100" kern="0" dirty="0">
+              <a:rPr lang="en-US" sz="5000" b="1" spc="-100" kern="0" dirty="0">
                 <a:solidFill>
                   <a:srgbClr val="17130D"/>
                 </a:solidFill>
@@ -8428,7 +8452,7 @@
               </a:rPr>
               <a:t>THANK YOU</a:t>
             </a:r>
-            <a:endParaRPr lang="en-US" sz="5400" dirty="0"/>
+            <a:endParaRPr lang="en-US" sz="5000" dirty="0"/>
           </a:p>
         </p:txBody>
       </p:sp>

</xml_diff>